<commit_message>
docs(ppt): update role distribution across Team Lead (Full-Stack/Software/AI) and Team Members (Cyber & AI streams)
</commit_message>
<xml_diff>
--- a/docs/SHIELD_AI_Master_Presentation.pptx
+++ b/docs/SHIELD_AI_Master_Presentation.pptx
@@ -3297,7 +3297,7 @@
               </a:defRPr>
             </a:pPr>
             <a:r>
-              <a:t>PROJECT LEADERSHIP &amp; TEAM COMPOSITION</a:t>
+              <a:t>PROJECT LEADERSHIP &amp; TEAM ROLES</a:t>
             </a:r>
           </a:p>
           <a:p>
@@ -3313,7 +3313,7 @@
               </a:defRPr>
             </a:pPr>
             <a:r>
-              <a:t>• Team Lead (TL): Gokula Kannan M (SEC25CS196 | CSE-A) — Systems Architecture &amp; Venture Strategy</a:t>
+              <a:t>• Team Lead (TL): Gokula Kannan M (SEC25CS196 | CSE-A) — Full-Stack Development, Software Engineering &amp; AI Integration</a:t>
             </a:r>
           </a:p>
           <a:p>
@@ -3329,7 +3329,7 @@
               </a:defRPr>
             </a:pPr>
             <a:r>
-              <a:t>• Team Member 1 (M1): Lakshan M (SEC25CS036 | CSE-A) — Full-Stack Dashboard Architect &amp; HITL UI</a:t>
+              <a:t>• Team Member 1 (M1): Lakshan M (SEC25CS036 | CSE-A) — Cybersecurity, Threat Modeling &amp; SIEM Active Defense</a:t>
             </a:r>
           </a:p>
           <a:p>
@@ -3345,7 +3345,7 @@
               </a:defRPr>
             </a:pPr>
             <a:r>
-              <a:t>• Team Member 2 (M2): Sivabalan T (SEC25CS101 | CSE-C) — AI Engine Architecture &amp; Zero-Trust Sanitizer</a:t>
+              <a:t>• Team Member 2 (M2): Sivabalan T (SEC25CS101 | CSE-C) — Core AI Engineering, Zero-Trust Privacy &amp; Quantization</a:t>
             </a:r>
           </a:p>
           <a:p>
@@ -3361,7 +3361,7 @@
               </a:defRPr>
             </a:pPr>
             <a:r>
-              <a:t>• Faculty Supervisor: Dr. A. SHEELA (Associate Professor, Dept. of Computer Science &amp; Engineering)</a:t>
+              <a:t>• Faculty Supervisor: Dr. A. SHEELA (Associate Professor, Department of Computer Science &amp; Engineering)</a:t>
             </a:r>
           </a:p>
           <a:p>
@@ -7408,7 +7408,7 @@
               </a:defRPr>
             </a:pPr>
             <a:r>
-              <a:t>Team Composition &amp; Division of Responsibilities</a:t>
+              <a:t>Team Composition &amp; Specialized Technical Roles</a:t>
             </a:r>
           </a:p>
         </p:txBody>
@@ -7478,9 +7478,9 @@
               </a:tblPr>
               <a:tblGrid>
                 <a:gridCol w="2011680"/>
-                <a:gridCol w="1828800"/>
+                <a:gridCol w="1920240"/>
                 <a:gridCol w="3200400"/>
-                <a:gridCol w="3687775"/>
+                <a:gridCol w="3596335"/>
               </a:tblGrid>
               <a:tr h="932688">
                 <a:tc>
@@ -7545,7 +7545,7 @@
                         </a:defRPr>
                       </a:pPr>
                       <a:r>
-                        <a:t>Core Technical Domain</a:t>
+                        <a:t>Technical Specialization</a:t>
                       </a:r>
                     </a:p>
                   </a:txBody>
@@ -7569,7 +7569,7 @@
                         </a:defRPr>
                       </a:pPr>
                       <a:r>
-                        <a:t>Project Deliverables &amp; Contributions</a:t>
+                        <a:t>Project Deliverables &amp; Ownership</a:t>
                       </a:r>
                     </a:p>
                   </a:txBody>
@@ -7587,7 +7587,7 @@
                     <a:lstStyle/>
                     <a:p>
                       <a:pPr>
-                        <a:defRPr sz="1000">
+                        <a:defRPr sz="950">
                           <a:solidFill>
                             <a:srgbClr val="1E293B"/>
                           </a:solidFill>
@@ -7611,7 +7611,7 @@
                     <a:lstStyle/>
                     <a:p>
                       <a:pPr>
-                        <a:defRPr sz="1000">
+                        <a:defRPr sz="950">
                           <a:solidFill>
                             <a:srgbClr val="1E293B"/>
                           </a:solidFill>
@@ -7639,7 +7639,7 @@
                     <a:lstStyle/>
                     <a:p>
                       <a:pPr>
-                        <a:defRPr sz="1000">
+                        <a:defRPr sz="950">
                           <a:solidFill>
                             <a:srgbClr val="1E293B"/>
                           </a:solidFill>
@@ -7647,7 +7647,7 @@
                         </a:defRPr>
                       </a:pPr>
                       <a:r>
-                        <a:t>Systems Architecture, Asynchronous Backends &amp; Venture Strategy</a:t>
+                        <a:t>Full-Stack Development, Software Engineering &amp; AI Integration</a:t>
                       </a:r>
                     </a:p>
                   </a:txBody>
@@ -7663,7 +7663,7 @@
                     <a:lstStyle/>
                     <a:p>
                       <a:pPr>
-                        <a:defRPr sz="1000">
+                        <a:defRPr sz="950">
                           <a:solidFill>
                             <a:srgbClr val="1E293B"/>
                           </a:solidFill>
@@ -7671,7 +7671,7 @@
                         </a:defRPr>
                       </a:pPr>
                       <a:r>
-                        <a:t>Overall system architecture, 3-Tier AI Router design, sprint management, leading national pitch at Hac'KP 2026 @ Zoho.</a:t>
+                        <a:t>Overall system architecture, async FastAPI backend, React dashboard integration, 3-Tier AI router pipeline, sprint leadership &amp; Hac'KP 2026 pitching.</a:t>
                       </a:r>
                     </a:p>
                   </a:txBody>
@@ -7689,7 +7689,7 @@
                     <a:lstStyle/>
                     <a:p>
                       <a:pPr>
-                        <a:defRPr sz="1000">
+                        <a:defRPr sz="950">
                           <a:solidFill>
                             <a:srgbClr val="1E293B"/>
                           </a:solidFill>
@@ -7713,7 +7713,7 @@
                     <a:lstStyle/>
                     <a:p>
                       <a:pPr>
-                        <a:defRPr sz="1000">
+                        <a:defRPr sz="950">
                           <a:solidFill>
                             <a:srgbClr val="1E293B"/>
                           </a:solidFill>
@@ -7741,7 +7741,7 @@
                     <a:lstStyle/>
                     <a:p>
                       <a:pPr>
-                        <a:defRPr sz="1000">
+                        <a:defRPr sz="950">
                           <a:solidFill>
                             <a:srgbClr val="1E293B"/>
                           </a:solidFill>
@@ -7749,7 +7749,7 @@
                         </a:defRPr>
                       </a:pPr>
                       <a:r>
-                        <a:t>Full-Stack Web Architecture, React.js UI &amp; WebSockets</a:t>
+                        <a:t>Cybersecurity, Threat Modeling &amp; SIEM Active Defense</a:t>
                       </a:r>
                     </a:p>
                   </a:txBody>
@@ -7765,7 +7765,7 @@
                     <a:lstStyle/>
                     <a:p>
                       <a:pPr>
-                        <a:defRPr sz="1000">
+                        <a:defRPr sz="950">
                           <a:solidFill>
                             <a:srgbClr val="1E293B"/>
                           </a:solidFill>
@@ -7773,7 +7773,7 @@
                         </a:defRPr>
                       </a:pPr>
                       <a:r>
-                        <a:t>Real-time incident dashboard engineering, WebSockets live feed, and Human-in-the-Loop (HITL) analyst approval interface.</a:t>
+                        <a:t>Wazuh SIEM active response ingestion bridge, MITRE ATT&amp;CK taxonomy mapper (src/mitre_mapper.py), attack graph correlation &amp; response controller.</a:t>
                       </a:r>
                     </a:p>
                   </a:txBody>
@@ -7791,7 +7791,7 @@
                     <a:lstStyle/>
                     <a:p>
                       <a:pPr>
-                        <a:defRPr sz="1000">
+                        <a:defRPr sz="950">
                           <a:solidFill>
                             <a:srgbClr val="1E293B"/>
                           </a:solidFill>
@@ -7815,7 +7815,7 @@
                     <a:lstStyle/>
                     <a:p>
                       <a:pPr>
-                        <a:defRPr sz="1000">
+                        <a:defRPr sz="950">
                           <a:solidFill>
                             <a:srgbClr val="1E293B"/>
                           </a:solidFill>
@@ -7843,7 +7843,7 @@
                     <a:lstStyle/>
                     <a:p>
                       <a:pPr>
-                        <a:defRPr sz="1000">
+                        <a:defRPr sz="950">
                           <a:solidFill>
                             <a:srgbClr val="1E293B"/>
                           </a:solidFill>
@@ -7851,7 +7851,7 @@
                         </a:defRPr>
                       </a:pPr>
                       <a:r>
-                        <a:t>AI Engine Architecture, Zero-Trust Privacy &amp; Quantization</a:t>
+                        <a:t>Core AI Engineering, Zero-Trust Privacy &amp; Quantization</a:t>
                       </a:r>
                     </a:p>
                   </a:txBody>
@@ -7867,7 +7867,7 @@
                     <a:lstStyle/>
                     <a:p>
                       <a:pPr>
-                        <a:defRPr sz="1000">
+                        <a:defRPr sz="950">
                           <a:solidFill>
                             <a:srgbClr val="1E293B"/>
                           </a:solidFill>
@@ -7875,7 +7875,7 @@
                         </a:defRPr>
                       </a:pPr>
                       <a:r>
-                        <a:t>Development of Zero-Trust Data Sanitizer (src/sanitizer.py), 3-Tier AI Router (src/router.py), and local GGUF quantization.</a:t>
+                        <a:t>Development of Zero-Trust Data Sanitizer (src/sanitizer.py), in-RAM token vault, Prompt Injection Firewall, ChromaDB RAG &amp; local GPU model quantization.</a:t>
                       </a:r>
                     </a:p>
                   </a:txBody>
@@ -7893,7 +7893,7 @@
                     <a:lstStyle/>
                     <a:p>
                       <a:pPr>
-                        <a:defRPr sz="1000">
+                        <a:defRPr sz="950">
                           <a:solidFill>
                             <a:srgbClr val="1E293B"/>
                           </a:solidFill>
@@ -7917,7 +7917,7 @@
                     <a:lstStyle/>
                     <a:p>
                       <a:pPr>
-                        <a:defRPr sz="1000">
+                        <a:defRPr sz="950">
                           <a:solidFill>
                             <a:srgbClr val="1E293B"/>
                           </a:solidFill>
@@ -7945,7 +7945,7 @@
                     <a:lstStyle/>
                     <a:p>
                       <a:pPr>
-                        <a:defRPr sz="1000">
+                        <a:defRPr sz="950">
                           <a:solidFill>
                             <a:srgbClr val="1E293B"/>
                           </a:solidFill>
@@ -7969,7 +7969,7 @@
                     <a:lstStyle/>
                     <a:p>
                       <a:pPr>
-                        <a:defRPr sz="1000">
+                        <a:defRPr sz="950">
                           <a:solidFill>
                             <a:srgbClr val="1E293B"/>
                           </a:solidFill>

</xml_diff>